<commit_message>
Aurkezpena + datubase access
</commit_message>
<xml_diff>
--- a/Aurkezpena/1.Erronka Aurkezpena.pptx
+++ b/Aurkezpena/1.Erronka Aurkezpena.pptx
@@ -313,7 +313,7 @@
           <a:p>
             <a:fld id="{1C60CDA0-A541-4C6F-AA03-59A25C3812BD}" type="datetimeFigureOut">
               <a:rPr lang="es-ES" smtClean="0"/>
-              <a:t>27/10/2026</a:t>
+              <a:t>28/10/2026</a:t>
             </a:fld>
             <a:endParaRPr lang="es-ES"/>
           </a:p>
@@ -588,7 +588,7 @@
           <a:p>
             <a:fld id="{1C60CDA0-A541-4C6F-AA03-59A25C3812BD}" type="datetimeFigureOut">
               <a:rPr lang="es-ES" smtClean="0"/>
-              <a:t>27/10/2026</a:t>
+              <a:t>28/10/2026</a:t>
             </a:fld>
             <a:endParaRPr lang="es-ES"/>
           </a:p>
@@ -782,7 +782,7 @@
           <a:p>
             <a:fld id="{1C60CDA0-A541-4C6F-AA03-59A25C3812BD}" type="datetimeFigureOut">
               <a:rPr lang="es-ES" smtClean="0"/>
-              <a:t>27/10/2026</a:t>
+              <a:t>28/10/2026</a:t>
             </a:fld>
             <a:endParaRPr lang="es-ES"/>
           </a:p>
@@ -1055,7 +1055,7 @@
           <a:p>
             <a:fld id="{1C60CDA0-A541-4C6F-AA03-59A25C3812BD}" type="datetimeFigureOut">
               <a:rPr lang="es-ES" smtClean="0"/>
-              <a:t>27/10/2026</a:t>
+              <a:t>28/10/2026</a:t>
             </a:fld>
             <a:endParaRPr lang="es-ES"/>
           </a:p>
@@ -1396,7 +1396,7 @@
           <a:p>
             <a:fld id="{1C60CDA0-A541-4C6F-AA03-59A25C3812BD}" type="datetimeFigureOut">
               <a:rPr lang="es-ES" smtClean="0"/>
-              <a:t>27/10/2026</a:t>
+              <a:t>28/10/2026</a:t>
             </a:fld>
             <a:endParaRPr lang="es-ES"/>
           </a:p>
@@ -2019,7 +2019,7 @@
           <a:p>
             <a:fld id="{1C60CDA0-A541-4C6F-AA03-59A25C3812BD}" type="datetimeFigureOut">
               <a:rPr lang="es-ES" smtClean="0"/>
-              <a:t>27/10/2026</a:t>
+              <a:t>28/10/2026</a:t>
             </a:fld>
             <a:endParaRPr lang="es-ES"/>
           </a:p>
@@ -2879,7 +2879,7 @@
           <a:p>
             <a:fld id="{1C60CDA0-A541-4C6F-AA03-59A25C3812BD}" type="datetimeFigureOut">
               <a:rPr lang="es-ES" smtClean="0"/>
-              <a:t>27/10/2026</a:t>
+              <a:t>28/10/2026</a:t>
             </a:fld>
             <a:endParaRPr lang="es-ES"/>
           </a:p>
@@ -3049,7 +3049,7 @@
           <a:p>
             <a:fld id="{1C60CDA0-A541-4C6F-AA03-59A25C3812BD}" type="datetimeFigureOut">
               <a:rPr lang="es-ES" smtClean="0"/>
-              <a:t>27/10/2026</a:t>
+              <a:t>28/10/2026</a:t>
             </a:fld>
             <a:endParaRPr lang="es-ES"/>
           </a:p>
@@ -3229,7 +3229,7 @@
           <a:p>
             <a:fld id="{1C60CDA0-A541-4C6F-AA03-59A25C3812BD}" type="datetimeFigureOut">
               <a:rPr lang="es-ES" smtClean="0"/>
-              <a:t>27/10/2026</a:t>
+              <a:t>28/10/2026</a:t>
             </a:fld>
             <a:endParaRPr lang="es-ES"/>
           </a:p>
@@ -3399,7 +3399,7 @@
           <a:p>
             <a:fld id="{1C60CDA0-A541-4C6F-AA03-59A25C3812BD}" type="datetimeFigureOut">
               <a:rPr lang="es-ES" smtClean="0"/>
-              <a:t>27/10/2026</a:t>
+              <a:t>28/10/2026</a:t>
             </a:fld>
             <a:endParaRPr lang="es-ES"/>
           </a:p>
@@ -3646,7 +3646,7 @@
           <a:p>
             <a:fld id="{1C60CDA0-A541-4C6F-AA03-59A25C3812BD}" type="datetimeFigureOut">
               <a:rPr lang="es-ES" smtClean="0"/>
-              <a:t>27/10/2026</a:t>
+              <a:t>28/10/2026</a:t>
             </a:fld>
             <a:endParaRPr lang="es-ES"/>
           </a:p>
@@ -3938,7 +3938,7 @@
           <a:p>
             <a:fld id="{1C60CDA0-A541-4C6F-AA03-59A25C3812BD}" type="datetimeFigureOut">
               <a:rPr lang="es-ES" smtClean="0"/>
-              <a:t>27/10/2026</a:t>
+              <a:t>28/10/2026</a:t>
             </a:fld>
             <a:endParaRPr lang="es-ES"/>
           </a:p>
@@ -4382,7 +4382,7 @@
           <a:p>
             <a:fld id="{1C60CDA0-A541-4C6F-AA03-59A25C3812BD}" type="datetimeFigureOut">
               <a:rPr lang="es-ES" smtClean="0"/>
-              <a:t>27/10/2026</a:t>
+              <a:t>28/10/2026</a:t>
             </a:fld>
             <a:endParaRPr lang="es-ES"/>
           </a:p>
@@ -4500,7 +4500,7 @@
           <a:p>
             <a:fld id="{1C60CDA0-A541-4C6F-AA03-59A25C3812BD}" type="datetimeFigureOut">
               <a:rPr lang="es-ES" smtClean="0"/>
-              <a:t>27/10/2026</a:t>
+              <a:t>28/10/2026</a:t>
             </a:fld>
             <a:endParaRPr lang="es-ES"/>
           </a:p>
@@ -4595,7 +4595,7 @@
           <a:p>
             <a:fld id="{1C60CDA0-A541-4C6F-AA03-59A25C3812BD}" type="datetimeFigureOut">
               <a:rPr lang="es-ES" smtClean="0"/>
-              <a:t>27/10/2026</a:t>
+              <a:t>28/10/2026</a:t>
             </a:fld>
             <a:endParaRPr lang="es-ES"/>
           </a:p>
@@ -4874,7 +4874,7 @@
           <a:p>
             <a:fld id="{1C60CDA0-A541-4C6F-AA03-59A25C3812BD}" type="datetimeFigureOut">
               <a:rPr lang="es-ES" smtClean="0"/>
-              <a:t>27/10/2026</a:t>
+              <a:t>28/10/2026</a:t>
             </a:fld>
             <a:endParaRPr lang="es-ES"/>
           </a:p>
@@ -5149,7 +5149,7 @@
           <a:p>
             <a:fld id="{1C60CDA0-A541-4C6F-AA03-59A25C3812BD}" type="datetimeFigureOut">
               <a:rPr lang="es-ES" smtClean="0"/>
-              <a:t>27/10/2026</a:t>
+              <a:t>28/10/2026</a:t>
             </a:fld>
             <a:endParaRPr lang="es-ES"/>
           </a:p>
@@ -5578,7 +5578,7 @@
           <a:p>
             <a:fld id="{1C60CDA0-A541-4C6F-AA03-59A25C3812BD}" type="datetimeFigureOut">
               <a:rPr lang="es-ES" smtClean="0"/>
-              <a:t>27/10/2026</a:t>
+              <a:t>28/10/2026</a:t>
             </a:fld>
             <a:endParaRPr lang="es-ES"/>
           </a:p>
@@ -6480,7 +6480,7 @@
         <p:spPr>
           <a:xfrm>
             <a:off x="1195583" y="3045377"/>
-            <a:ext cx="2314533" cy="2003323"/>
+            <a:ext cx="6129449" cy="1035010"/>
           </a:xfrm>
         </p:spPr>
         <p:txBody>
@@ -6494,50 +6494,23 @@
             </a:pPr>
             <a:r>
               <a:rPr lang="eu-ES" sz="1400" b="1" noProof="0" dirty="0"/>
-              <a:t>Emandako Espezifikazioak:</a:t>
-            </a:r>
-          </a:p>
-          <a:p>
-            <a:pPr>
-              <a:buFontTx/>
-              <a:buChar char="-"/>
+              <a:t>Hardwarea: 3 disko gogor, bakoitza 50GB </a:t>
+            </a:r>
+            <a:r>
+              <a:rPr lang="eu-ES" sz="1400" b="1" noProof="0" dirty="0" err="1"/>
+              <a:t>koa</a:t>
+            </a:r>
+            <a:endParaRPr lang="eu-ES" sz="1400" b="1" noProof="0" dirty="0"/>
+          </a:p>
+          <a:p>
+            <a:pPr marL="0" indent="0">
+              <a:buNone/>
             </a:pPr>
             <a:r>
               <a:rPr lang="eu-ES" sz="1400" b="1" dirty="0"/>
-              <a:t>4gb</a:t>
-            </a:r>
-          </a:p>
-          <a:p>
-            <a:pPr>
-              <a:buFontTx/>
-              <a:buChar char="-"/>
-            </a:pPr>
-            <a:r>
-              <a:rPr lang="eu-ES" sz="1400" b="1" dirty="0"/>
-              <a:t>2 </a:t>
-            </a:r>
-            <a:r>
-              <a:rPr lang="eu-ES" sz="1400" b="1" dirty="0" err="1"/>
-              <a:t>cpu</a:t>
-            </a:r>
-            <a:endParaRPr lang="eu-ES" sz="1400" b="1" dirty="0"/>
-          </a:p>
-          <a:p>
-            <a:pPr>
-              <a:buFontTx/>
-              <a:buChar char="-"/>
-            </a:pPr>
-            <a:r>
-              <a:rPr lang="eu-ES" sz="1400" b="1" dirty="0"/>
-              <a:t>50gb sistema eragile</a:t>
-            </a:r>
-          </a:p>
-          <a:p>
-            <a:pPr>
-              <a:buFontTx/>
-              <a:buChar char="-"/>
-            </a:pPr>
-            <a:endParaRPr lang="eu-ES" sz="1400" b="1" dirty="0"/>
+              <a:t>Bolumen kopurua: 1 (100GB)</a:t>
+            </a:r>
+            <a:endParaRPr lang="eu-ES" sz="1400" b="1" noProof="0" dirty="0"/>
           </a:p>
         </p:txBody>
       </p:sp>
@@ -6589,6 +6562,42 @@
           </a:p>
         </p:txBody>
       </p:sp>
+      <p:pic>
+        <p:nvPicPr>
+          <p:cNvPr id="6" name="Imagen 5">
+            <a:extLst>
+              <a:ext uri="{FF2B5EF4-FFF2-40B4-BE49-F238E27FC236}">
+                <a16:creationId xmlns:a16="http://schemas.microsoft.com/office/drawing/2014/main" id="{52F9C7EC-0306-2D75-F887-9F3456C40F87}"/>
+              </a:ext>
+            </a:extLst>
+          </p:cNvPr>
+          <p:cNvPicPr>
+            <a:picLocks noChangeAspect="1"/>
+          </p:cNvPicPr>
+          <p:nvPr/>
+        </p:nvPicPr>
+        <p:blipFill>
+          <a:blip r:embed="rId2">
+            <a:extLst>
+              <a:ext uri="{28A0092B-C50C-407E-A947-70E740481C1C}">
+                <a14:useLocalDpi xmlns:a14="http://schemas.microsoft.com/office/drawing/2010/main" val="0"/>
+              </a:ext>
+            </a:extLst>
+          </a:blip>
+          <a:stretch>
+            <a:fillRect/>
+          </a:stretch>
+        </p:blipFill>
+        <p:spPr>
+          <a:xfrm>
+            <a:off x="6764593" y="2015613"/>
+            <a:ext cx="4272453" cy="4002045"/>
+          </a:xfrm>
+          <a:prstGeom prst="rect">
+            <a:avLst/>
+          </a:prstGeom>
+        </p:spPr>
+      </p:pic>
     </p:spTree>
     <p:extLst>
       <p:ext uri="{BB962C8B-B14F-4D97-AF65-F5344CB8AC3E}">
@@ -6678,7 +6687,7 @@
         <p:spPr>
           <a:xfrm>
             <a:off x="1195583" y="3045377"/>
-            <a:ext cx="2314533" cy="2003323"/>
+            <a:ext cx="4526792" cy="2003323"/>
           </a:xfrm>
         </p:spPr>
         <p:txBody>
@@ -6692,7 +6701,7 @@
             </a:pPr>
             <a:r>
               <a:rPr lang="eu-ES" sz="1400" b="1" noProof="0" dirty="0"/>
-              <a:t>Emandako Espezifikazioak:</a:t>
+              <a:t>Sortu dugun RAID = RAID 5</a:t>
             </a:r>
           </a:p>
           <a:p>
@@ -6702,7 +6711,15 @@
             </a:pPr>
             <a:r>
               <a:rPr lang="eu-ES" sz="1400" b="1" dirty="0"/>
-              <a:t>4gb</a:t>
+              <a:t>Segurtasuna (</a:t>
+            </a:r>
+            <a:r>
+              <a:rPr lang="eu-ES" sz="1400" b="1" dirty="0" err="1"/>
+              <a:t>Parietatea</a:t>
+            </a:r>
+            <a:r>
+              <a:rPr lang="eu-ES" sz="1400" b="1" dirty="0"/>
+              <a:t>)</a:t>
             </a:r>
           </a:p>
           <a:p>
@@ -6712,13 +6729,16 @@
             </a:pPr>
             <a:r>
               <a:rPr lang="eu-ES" sz="1400" b="1" dirty="0"/>
-              <a:t>2 </a:t>
+              <a:t>3 diskoetatik 2ren memoria erabilgarri dugu (3.na </a:t>
             </a:r>
             <a:r>
               <a:rPr lang="eu-ES" sz="1400" b="1" dirty="0" err="1"/>
-              <a:t>cpu</a:t>
-            </a:r>
-            <a:endParaRPr lang="eu-ES" sz="1400" b="1" dirty="0"/>
+              <a:t>parietaterako</a:t>
+            </a:r>
+            <a:r>
+              <a:rPr lang="eu-ES" sz="1400" b="1" dirty="0"/>
+              <a:t> geratuko da.)</a:t>
+            </a:r>
           </a:p>
           <a:p>
             <a:pPr>
@@ -6727,15 +6747,8 @@
             </a:pPr>
             <a:r>
               <a:rPr lang="eu-ES" sz="1400" b="1" dirty="0"/>
-              <a:t>50gb sistema eragile</a:t>
-            </a:r>
-          </a:p>
-          <a:p>
-            <a:pPr>
-              <a:buFontTx/>
-              <a:buChar char="-"/>
-            </a:pPr>
-            <a:endParaRPr lang="eu-ES" sz="1400" b="1" dirty="0"/>
+              <a:t>Disko 1 apurtzen bada, sistemak martxan jarraitu dezake datuak galdu gabe disko gogorra aldatu arte.</a:t>
+            </a:r>
           </a:p>
         </p:txBody>
       </p:sp>
@@ -6774,6 +6787,42 @@
           </a:p>
         </p:txBody>
       </p:sp>
+      <p:pic>
+        <p:nvPicPr>
+          <p:cNvPr id="6" name="Imagen 5">
+            <a:extLst>
+              <a:ext uri="{FF2B5EF4-FFF2-40B4-BE49-F238E27FC236}">
+                <a16:creationId xmlns:a16="http://schemas.microsoft.com/office/drawing/2014/main" id="{DF95EDD8-B103-FE11-CCCD-5FC19E404847}"/>
+              </a:ext>
+            </a:extLst>
+          </p:cNvPr>
+          <p:cNvPicPr>
+            <a:picLocks noChangeAspect="1"/>
+          </p:cNvPicPr>
+          <p:nvPr/>
+        </p:nvPicPr>
+        <p:blipFill>
+          <a:blip r:embed="rId2">
+            <a:extLst>
+              <a:ext uri="{28A0092B-C50C-407E-A947-70E740481C1C}">
+                <a14:useLocalDpi xmlns:a14="http://schemas.microsoft.com/office/drawing/2010/main" val="0"/>
+              </a:ext>
+            </a:extLst>
+          </a:blip>
+          <a:stretch>
+            <a:fillRect/>
+          </a:stretch>
+        </p:blipFill>
+        <p:spPr>
+          <a:xfrm>
+            <a:off x="6874223" y="2445774"/>
+            <a:ext cx="4206732" cy="3783227"/>
+          </a:xfrm>
+          <a:prstGeom prst="rect">
+            <a:avLst/>
+          </a:prstGeom>
+        </p:spPr>
+      </p:pic>
     </p:spTree>
     <p:extLst>
       <p:ext uri="{BB962C8B-B14F-4D97-AF65-F5344CB8AC3E}">
@@ -6863,22 +6912,19 @@
         <p:spPr>
           <a:xfrm>
             <a:off x="1195583" y="3045377"/>
-            <a:ext cx="2314533" cy="2003323"/>
+            <a:ext cx="4379307" cy="2003323"/>
           </a:xfrm>
         </p:spPr>
         <p:txBody>
           <a:bodyPr>
-            <a:normAutofit/>
+            <a:normAutofit lnSpcReduction="10000"/>
           </a:bodyPr>
           <a:lstStyle/>
           <a:p>
             <a:pPr marL="0" indent="0">
               <a:buNone/>
             </a:pPr>
-            <a:r>
-              <a:rPr lang="eu-ES" sz="1400" b="1" noProof="0" dirty="0"/>
-              <a:t>Emandako Espezifikazioak:</a:t>
-            </a:r>
+            <a:endParaRPr lang="eu-ES" sz="1400" b="1" noProof="0" dirty="0"/>
           </a:p>
           <a:p>
             <a:pPr>
@@ -6886,8 +6932,8 @@
               <a:buChar char="-"/>
             </a:pPr>
             <a:r>
-              <a:rPr lang="eu-ES" sz="1400" b="1" dirty="0"/>
-              <a:t>4gb</a:t>
+              <a:rPr lang="eu-ES" sz="2400" b="1" dirty="0"/>
+              <a:t>IIS web zerbitzaria</a:t>
             </a:r>
           </a:p>
           <a:p>
@@ -6896,14 +6942,13 @@
               <a:buChar char="-"/>
             </a:pPr>
             <a:r>
-              <a:rPr lang="eu-ES" sz="1400" b="1" dirty="0"/>
-              <a:t>2 </a:t>
-            </a:r>
-            <a:r>
-              <a:rPr lang="eu-ES" sz="1400" b="1" dirty="0" err="1"/>
-              <a:t>cpu</a:t>
-            </a:r>
-            <a:endParaRPr lang="eu-ES" sz="1400" b="1" dirty="0"/>
+              <a:rPr lang="eu-ES" sz="2400" b="1" dirty="0" err="1"/>
+              <a:t>Iscsi</a:t>
+            </a:r>
+            <a:r>
+              <a:rPr lang="eu-ES" sz="2400" b="1" dirty="0"/>
+              <a:t> (Karpeten kuoten administratzailea)</a:t>
+            </a:r>
           </a:p>
           <a:p>
             <a:pPr>
@@ -6911,16 +6956,22 @@
               <a:buChar char="-"/>
             </a:pPr>
             <a:r>
-              <a:rPr lang="eu-ES" sz="1400" b="1" dirty="0"/>
-              <a:t>50gb sistema eragile</a:t>
-            </a:r>
-          </a:p>
-          <a:p>
-            <a:pPr>
-              <a:buFontTx/>
-              <a:buChar char="-"/>
-            </a:pPr>
-            <a:endParaRPr lang="eu-ES" sz="1400" b="1" dirty="0"/>
+              <a:rPr lang="eu-ES" sz="2400" b="1" dirty="0"/>
+              <a:t>Windows </a:t>
+            </a:r>
+            <a:r>
+              <a:rPr lang="eu-ES" sz="2400" b="1" dirty="0" err="1"/>
+              <a:t>server</a:t>
+            </a:r>
+            <a:r>
+              <a:rPr lang="eu-ES" sz="2400" b="1" dirty="0"/>
+              <a:t> </a:t>
+            </a:r>
+            <a:r>
+              <a:rPr lang="eu-ES" sz="2400" b="1" dirty="0" err="1"/>
+              <a:t>backup</a:t>
+            </a:r>
+            <a:endParaRPr lang="eu-ES" sz="2400" b="1" dirty="0"/>
           </a:p>
         </p:txBody>
       </p:sp>
@@ -6984,37 +7035,46 @@
               <a:rPr lang="es-ES" sz="2000" dirty="0" err="1"/>
               <a:t>gehitu</a:t>
             </a:r>
-            <a:r>
-              <a:rPr lang="es-ES" sz="2000" dirty="0"/>
-              <a:t> (IIS, </a:t>
-            </a:r>
-            <a:r>
-              <a:rPr lang="es-ES" sz="2000" dirty="0" err="1"/>
-              <a:t>iSCSI</a:t>
-            </a:r>
-            <a:r>
-              <a:rPr lang="es-ES" sz="2000" dirty="0"/>
-              <a:t> eta </a:t>
-            </a:r>
-            <a:r>
-              <a:rPr lang="es-ES" sz="2000" dirty="0" err="1"/>
-              <a:t>Segurtasun</a:t>
-            </a:r>
-            <a:r>
-              <a:rPr lang="es-ES" sz="2000" dirty="0"/>
-              <a:t> </a:t>
-            </a:r>
-            <a:r>
-              <a:rPr lang="es-ES" sz="2000" dirty="0" err="1"/>
-              <a:t>kopiak</a:t>
-            </a:r>
-            <a:r>
-              <a:rPr lang="es-ES" sz="2000" dirty="0"/>
-              <a:t>)</a:t>
-            </a:r>
-          </a:p>
-        </p:txBody>
-      </p:sp>
+            <a:endParaRPr lang="es-ES" sz="2000" dirty="0"/>
+          </a:p>
+        </p:txBody>
+      </p:sp>
+      <p:pic>
+        <p:nvPicPr>
+          <p:cNvPr id="6" name="Imagen 5">
+            <a:extLst>
+              <a:ext uri="{FF2B5EF4-FFF2-40B4-BE49-F238E27FC236}">
+                <a16:creationId xmlns:a16="http://schemas.microsoft.com/office/drawing/2014/main" id="{4343D234-A3DE-9FF8-A439-848D5F5BEE81}"/>
+              </a:ext>
+            </a:extLst>
+          </p:cNvPr>
+          <p:cNvPicPr>
+            <a:picLocks noChangeAspect="1"/>
+          </p:cNvPicPr>
+          <p:nvPr/>
+        </p:nvPicPr>
+        <p:blipFill>
+          <a:blip r:embed="rId2">
+            <a:extLst>
+              <a:ext uri="{28A0092B-C50C-407E-A947-70E740481C1C}">
+                <a14:useLocalDpi xmlns:a14="http://schemas.microsoft.com/office/drawing/2010/main" val="0"/>
+              </a:ext>
+            </a:extLst>
+          </a:blip>
+          <a:stretch>
+            <a:fillRect/>
+          </a:stretch>
+        </p:blipFill>
+        <p:spPr>
+          <a:xfrm>
+            <a:off x="6882601" y="2445774"/>
+            <a:ext cx="4113816" cy="3849328"/>
+          </a:xfrm>
+          <a:prstGeom prst="rect">
+            <a:avLst/>
+          </a:prstGeom>
+        </p:spPr>
+      </p:pic>
     </p:spTree>
     <p:extLst>
       <p:ext uri="{BB962C8B-B14F-4D97-AF65-F5344CB8AC3E}">
@@ -7320,8 +7380,8 @@
         </p:nvSpPr>
         <p:spPr>
           <a:xfrm>
-            <a:off x="1195583" y="3045377"/>
-            <a:ext cx="2314533" cy="2003323"/>
+            <a:off x="989105" y="3311012"/>
+            <a:ext cx="5506387" cy="1981201"/>
           </a:xfrm>
         </p:spPr>
         <p:txBody>
@@ -7329,23 +7389,14 @@
             <a:normAutofit/>
           </a:bodyPr>
           <a:lstStyle/>
-          <a:p>
-            <a:pPr marL="0" indent="0">
-              <a:buNone/>
-            </a:pPr>
-            <a:r>
-              <a:rPr lang="eu-ES" sz="1400" b="1" noProof="0" dirty="0"/>
-              <a:t>Emandako Espezifikazioak:</a:t>
-            </a:r>
-          </a:p>
           <a:p>
             <a:pPr>
               <a:buFontTx/>
               <a:buChar char="-"/>
             </a:pPr>
             <a:r>
-              <a:rPr lang="eu-ES" sz="1400" b="1" dirty="0"/>
-              <a:t>4gb</a:t>
+              <a:rPr lang="eu-ES" sz="1800" b="1" dirty="0"/>
+              <a:t>ISS ADMINSITRATZAILETIK KONFIGURATU </a:t>
             </a:r>
           </a:p>
           <a:p>
@@ -7354,14 +7405,9 @@
               <a:buChar char="-"/>
             </a:pPr>
             <a:r>
-              <a:rPr lang="eu-ES" sz="1400" b="1" dirty="0"/>
-              <a:t>2 </a:t>
-            </a:r>
-            <a:r>
-              <a:rPr lang="eu-ES" sz="1400" b="1" dirty="0" err="1"/>
-              <a:t>cpu</a:t>
-            </a:r>
-            <a:endParaRPr lang="eu-ES" sz="1400" b="1" dirty="0"/>
+              <a:rPr lang="eu-ES" sz="1800" b="1" dirty="0"/>
+              <a:t>ZERBITZARIKO ERABILTZAILEEN BAIMENAK MUGATU + KANPOKO ERABILTZAILEEI BAIMENAK EMAN (IUSR)</a:t>
+            </a:r>
           </a:p>
           <a:p>
             <a:pPr>
@@ -7369,16 +7415,9 @@
               <a:buChar char="-"/>
             </a:pPr>
             <a:r>
-              <a:rPr lang="eu-ES" sz="1400" b="1" dirty="0"/>
-              <a:t>50gb sistema eragile</a:t>
-            </a:r>
-          </a:p>
-          <a:p>
-            <a:pPr>
-              <a:buFontTx/>
-              <a:buChar char="-"/>
-            </a:pPr>
-            <a:endParaRPr lang="eu-ES" sz="1400" b="1" dirty="0"/>
+              <a:rPr lang="eu-ES" sz="1800" b="1" dirty="0"/>
+              <a:t>FIREWALL SALBUESPENA JARRI (8080 PORTUA)</a:t>
+            </a:r>
           </a:p>
         </p:txBody>
       </p:sp>
@@ -7425,6 +7464,42 @@
           </a:p>
         </p:txBody>
       </p:sp>
+      <p:pic>
+        <p:nvPicPr>
+          <p:cNvPr id="6" name="Imagen 5">
+            <a:extLst>
+              <a:ext uri="{FF2B5EF4-FFF2-40B4-BE49-F238E27FC236}">
+                <a16:creationId xmlns:a16="http://schemas.microsoft.com/office/drawing/2014/main" id="{1CC413D6-1A67-AA2C-808F-EA7A3D774B5A}"/>
+              </a:ext>
+            </a:extLst>
+          </p:cNvPr>
+          <p:cNvPicPr>
+            <a:picLocks noChangeAspect="1"/>
+          </p:cNvPicPr>
+          <p:nvPr/>
+        </p:nvPicPr>
+        <p:blipFill>
+          <a:blip r:embed="rId2">
+            <a:extLst>
+              <a:ext uri="{28A0092B-C50C-407E-A947-70E740481C1C}">
+                <a14:useLocalDpi xmlns:a14="http://schemas.microsoft.com/office/drawing/2010/main" val="0"/>
+              </a:ext>
+            </a:extLst>
+          </a:blip>
+          <a:stretch>
+            <a:fillRect/>
+          </a:stretch>
+        </p:blipFill>
+        <p:spPr>
+          <a:xfrm>
+            <a:off x="6701970" y="2140726"/>
+            <a:ext cx="4162675" cy="3812623"/>
+          </a:xfrm>
+          <a:prstGeom prst="rect">
+            <a:avLst/>
+          </a:prstGeom>
+        </p:spPr>
+      </p:pic>
     </p:spTree>
     <p:extLst>
       <p:ext uri="{BB962C8B-B14F-4D97-AF65-F5344CB8AC3E}">
@@ -8806,7 +8881,7 @@
         <p:spPr>
           <a:xfrm>
             <a:off x="1195583" y="3045377"/>
-            <a:ext cx="2314533" cy="2003323"/>
+            <a:ext cx="2690942" cy="1841255"/>
           </a:xfrm>
         </p:spPr>
         <p:txBody>
@@ -8830,7 +8905,7 @@
             </a:pPr>
             <a:r>
               <a:rPr lang="eu-ES" sz="1400" b="1" dirty="0"/>
-              <a:t>4gb</a:t>
+              <a:t>4GB RAM</a:t>
             </a:r>
           </a:p>
           <a:p>
@@ -8840,13 +8915,8 @@
             </a:pPr>
             <a:r>
               <a:rPr lang="eu-ES" sz="1400" b="1" dirty="0"/>
-              <a:t>2 </a:t>
-            </a:r>
-            <a:r>
-              <a:rPr lang="eu-ES" sz="1400" b="1" dirty="0" err="1"/>
-              <a:t>cpu</a:t>
-            </a:r>
-            <a:endParaRPr lang="eu-ES" sz="1400" b="1" dirty="0"/>
+              <a:t>4 CPU</a:t>
+            </a:r>
           </a:p>
           <a:p>
             <a:pPr>
@@ -8855,7 +8925,7 @@
             </a:pPr>
             <a:r>
               <a:rPr lang="eu-ES" sz="1400" b="1" dirty="0"/>
-              <a:t>50gb sistema eragile</a:t>
+              <a:t>50GB Diskoa (Sistema eragilea)</a:t>
             </a:r>
           </a:p>
           <a:p>
@@ -8926,6 +8996,712 @@
           </a:p>
         </p:txBody>
       </p:sp>
+      <p:sp>
+        <p:nvSpPr>
+          <p:cNvPr id="5" name="Marcador de contenido 2">
+            <a:extLst>
+              <a:ext uri="{FF2B5EF4-FFF2-40B4-BE49-F238E27FC236}">
+                <a16:creationId xmlns:a16="http://schemas.microsoft.com/office/drawing/2014/main" id="{E013BB24-A3B5-D1D6-53C0-D6444932DB42}"/>
+              </a:ext>
+            </a:extLst>
+          </p:cNvPr>
+          <p:cNvSpPr txBox="1">
+            <a:spLocks/>
+          </p:cNvSpPr>
+          <p:nvPr/>
+        </p:nvSpPr>
+        <p:spPr>
+          <a:xfrm>
+            <a:off x="4491522" y="3045377"/>
+            <a:ext cx="3077184" cy="1910082"/>
+          </a:xfrm>
+          <a:prstGeom prst="rect">
+            <a:avLst/>
+          </a:prstGeom>
+        </p:spPr>
+        <p:txBody>
+          <a:bodyPr vert="horz" lIns="91440" tIns="45720" rIns="91440" bIns="45720" rtlCol="0" anchor="ctr">
+            <a:normAutofit/>
+          </a:bodyPr>
+          <a:lstStyle>
+            <a:lvl1pPr marL="342900" indent="-342900" algn="l" defTabSz="457200" rtl="0" eaLnBrk="1" latinLnBrk="0" hangingPunct="1">
+              <a:spcBef>
+                <a:spcPts val="1000"/>
+              </a:spcBef>
+              <a:spcAft>
+                <a:spcPts val="0"/>
+              </a:spcAft>
+              <a:buClr>
+                <a:schemeClr val="bg2">
+                  <a:lumMod val="40000"/>
+                  <a:lumOff val="60000"/>
+                </a:schemeClr>
+              </a:buClr>
+              <a:buSzPct val="80000"/>
+              <a:buFont typeface="Wingdings 3" charset="2"/>
+              <a:buChar char=""/>
+              <a:defRPr sz="2000" b="0" i="0" kern="1200">
+                <a:solidFill>
+                  <a:schemeClr val="tx1"/>
+                </a:solidFill>
+                <a:latin typeface="+mj-lt"/>
+                <a:ea typeface="+mj-ea"/>
+                <a:cs typeface="+mj-cs"/>
+              </a:defRPr>
+            </a:lvl1pPr>
+            <a:lvl2pPr marL="742950" indent="-285750" algn="l" defTabSz="457200" rtl="0" eaLnBrk="1" latinLnBrk="0" hangingPunct="1">
+              <a:spcBef>
+                <a:spcPts val="1000"/>
+              </a:spcBef>
+              <a:spcAft>
+                <a:spcPts val="0"/>
+              </a:spcAft>
+              <a:buClr>
+                <a:schemeClr val="bg2">
+                  <a:lumMod val="40000"/>
+                  <a:lumOff val="60000"/>
+                </a:schemeClr>
+              </a:buClr>
+              <a:buSzPct val="80000"/>
+              <a:buFont typeface="Wingdings 3" charset="2"/>
+              <a:buChar char=""/>
+              <a:defRPr sz="1800" b="0" i="0" kern="1200">
+                <a:solidFill>
+                  <a:schemeClr val="tx1"/>
+                </a:solidFill>
+                <a:latin typeface="+mj-lt"/>
+                <a:ea typeface="+mj-ea"/>
+                <a:cs typeface="+mj-cs"/>
+              </a:defRPr>
+            </a:lvl2pPr>
+            <a:lvl3pPr marL="1143000" indent="-228600" algn="l" defTabSz="457200" rtl="0" eaLnBrk="1" latinLnBrk="0" hangingPunct="1">
+              <a:spcBef>
+                <a:spcPts val="1000"/>
+              </a:spcBef>
+              <a:spcAft>
+                <a:spcPts val="0"/>
+              </a:spcAft>
+              <a:buClr>
+                <a:schemeClr val="bg2">
+                  <a:lumMod val="40000"/>
+                  <a:lumOff val="60000"/>
+                </a:schemeClr>
+              </a:buClr>
+              <a:buSzPct val="80000"/>
+              <a:buFont typeface="Wingdings 3" charset="2"/>
+              <a:buChar char=""/>
+              <a:defRPr sz="1600" b="0" i="0" kern="1200">
+                <a:solidFill>
+                  <a:schemeClr val="tx1"/>
+                </a:solidFill>
+                <a:latin typeface="+mj-lt"/>
+                <a:ea typeface="+mj-ea"/>
+                <a:cs typeface="+mj-cs"/>
+              </a:defRPr>
+            </a:lvl3pPr>
+            <a:lvl4pPr marL="1600200" indent="-228600" algn="l" defTabSz="457200" rtl="0" eaLnBrk="1" latinLnBrk="0" hangingPunct="1">
+              <a:spcBef>
+                <a:spcPts val="1000"/>
+              </a:spcBef>
+              <a:spcAft>
+                <a:spcPts val="0"/>
+              </a:spcAft>
+              <a:buClr>
+                <a:schemeClr val="bg2">
+                  <a:lumMod val="40000"/>
+                  <a:lumOff val="60000"/>
+                </a:schemeClr>
+              </a:buClr>
+              <a:buSzPct val="80000"/>
+              <a:buFont typeface="Wingdings 3" charset="2"/>
+              <a:buChar char=""/>
+              <a:defRPr sz="1400" b="0" i="0" kern="1200">
+                <a:solidFill>
+                  <a:schemeClr val="tx1"/>
+                </a:solidFill>
+                <a:latin typeface="+mj-lt"/>
+                <a:ea typeface="+mj-ea"/>
+                <a:cs typeface="+mj-cs"/>
+              </a:defRPr>
+            </a:lvl4pPr>
+            <a:lvl5pPr marL="2057400" indent="-228600" algn="l" defTabSz="457200" rtl="0" eaLnBrk="1" latinLnBrk="0" hangingPunct="1">
+              <a:spcBef>
+                <a:spcPts val="1000"/>
+              </a:spcBef>
+              <a:spcAft>
+                <a:spcPts val="0"/>
+              </a:spcAft>
+              <a:buClr>
+                <a:schemeClr val="bg2">
+                  <a:lumMod val="40000"/>
+                  <a:lumOff val="60000"/>
+                </a:schemeClr>
+              </a:buClr>
+              <a:buSzPct val="80000"/>
+              <a:buFont typeface="Wingdings 3" charset="2"/>
+              <a:buChar char=""/>
+              <a:defRPr sz="1400" b="0" i="0" kern="1200">
+                <a:solidFill>
+                  <a:schemeClr val="tx1"/>
+                </a:solidFill>
+                <a:latin typeface="+mj-lt"/>
+                <a:ea typeface="+mj-ea"/>
+                <a:cs typeface="+mj-cs"/>
+              </a:defRPr>
+            </a:lvl5pPr>
+            <a:lvl6pPr marL="2506000" indent="-228600" algn="l" defTabSz="457200" rtl="0" eaLnBrk="1" latinLnBrk="0" hangingPunct="1">
+              <a:spcBef>
+                <a:spcPts val="1000"/>
+              </a:spcBef>
+              <a:spcAft>
+                <a:spcPts val="0"/>
+              </a:spcAft>
+              <a:buClr>
+                <a:schemeClr val="bg2">
+                  <a:lumMod val="40000"/>
+                  <a:lumOff val="60000"/>
+                </a:schemeClr>
+              </a:buClr>
+              <a:buSzPct val="80000"/>
+              <a:buFont typeface="Wingdings 3" charset="2"/>
+              <a:buChar char=""/>
+              <a:defRPr sz="1400" b="0" i="0" kern="1200">
+                <a:solidFill>
+                  <a:schemeClr val="tx1"/>
+                </a:solidFill>
+                <a:latin typeface="+mj-lt"/>
+                <a:ea typeface="+mj-ea"/>
+                <a:cs typeface="+mj-cs"/>
+              </a:defRPr>
+            </a:lvl6pPr>
+            <a:lvl7pPr marL="2971800" indent="-228600" algn="l" defTabSz="457200" rtl="0" eaLnBrk="1" latinLnBrk="0" hangingPunct="1">
+              <a:spcBef>
+                <a:spcPts val="1000"/>
+              </a:spcBef>
+              <a:spcAft>
+                <a:spcPts val="0"/>
+              </a:spcAft>
+              <a:buClr>
+                <a:schemeClr val="bg2">
+                  <a:lumMod val="40000"/>
+                  <a:lumOff val="60000"/>
+                </a:schemeClr>
+              </a:buClr>
+              <a:buSzPct val="80000"/>
+              <a:buFont typeface="Wingdings 3" charset="2"/>
+              <a:buChar char=""/>
+              <a:defRPr sz="1400" b="0" i="0" kern="1200">
+                <a:solidFill>
+                  <a:schemeClr val="tx1"/>
+                </a:solidFill>
+                <a:latin typeface="+mj-lt"/>
+                <a:ea typeface="+mj-ea"/>
+                <a:cs typeface="+mj-cs"/>
+              </a:defRPr>
+            </a:lvl7pPr>
+            <a:lvl8pPr marL="3429000" indent="-228600" algn="l" defTabSz="457200" rtl="0" eaLnBrk="1" latinLnBrk="0" hangingPunct="1">
+              <a:spcBef>
+                <a:spcPts val="1000"/>
+              </a:spcBef>
+              <a:spcAft>
+                <a:spcPts val="0"/>
+              </a:spcAft>
+              <a:buClr>
+                <a:schemeClr val="bg2">
+                  <a:lumMod val="40000"/>
+                  <a:lumOff val="60000"/>
+                </a:schemeClr>
+              </a:buClr>
+              <a:buSzPct val="80000"/>
+              <a:buFont typeface="Wingdings 3" charset="2"/>
+              <a:buChar char=""/>
+              <a:defRPr sz="1400" b="0" i="0" kern="1200">
+                <a:solidFill>
+                  <a:schemeClr val="tx1"/>
+                </a:solidFill>
+                <a:latin typeface="+mj-lt"/>
+                <a:ea typeface="+mj-ea"/>
+                <a:cs typeface="+mj-cs"/>
+              </a:defRPr>
+            </a:lvl8pPr>
+            <a:lvl9pPr marL="3886200" indent="-228600" algn="l" defTabSz="457200" rtl="0" eaLnBrk="1" latinLnBrk="0" hangingPunct="1">
+              <a:spcBef>
+                <a:spcPts val="1000"/>
+              </a:spcBef>
+              <a:spcAft>
+                <a:spcPts val="0"/>
+              </a:spcAft>
+              <a:buClr>
+                <a:schemeClr val="bg2">
+                  <a:lumMod val="40000"/>
+                  <a:lumOff val="60000"/>
+                </a:schemeClr>
+              </a:buClr>
+              <a:buSzPct val="80000"/>
+              <a:buFont typeface="Wingdings 3" charset="2"/>
+              <a:buChar char=""/>
+              <a:defRPr sz="1400" b="0" i="0" kern="1200">
+                <a:solidFill>
+                  <a:schemeClr val="tx1"/>
+                </a:solidFill>
+                <a:latin typeface="+mj-lt"/>
+                <a:ea typeface="+mj-ea"/>
+                <a:cs typeface="+mj-cs"/>
+              </a:defRPr>
+            </a:lvl9pPr>
+          </a:lstStyle>
+          <a:p>
+            <a:pPr marL="0" indent="0">
+              <a:buFont typeface="Wingdings 3" charset="2"/>
+              <a:buNone/>
+            </a:pPr>
+            <a:r>
+              <a:rPr lang="eu-ES" sz="1400" b="1" dirty="0"/>
+              <a:t>Instalatu duguna:</a:t>
+            </a:r>
+          </a:p>
+          <a:p>
+            <a:pPr>
+              <a:buFontTx/>
+              <a:buChar char="-"/>
+            </a:pPr>
+            <a:r>
+              <a:rPr lang="de-DE" sz="1400" b="1" dirty="0"/>
+              <a:t>Windows Server 2025 x64 es-ES</a:t>
+            </a:r>
+            <a:r>
+              <a:rPr lang="eu-ES" sz="1400" b="1" dirty="0"/>
+              <a:t>4 CPU</a:t>
+            </a:r>
+          </a:p>
+          <a:p>
+            <a:pPr>
+              <a:buFontTx/>
+              <a:buChar char="-"/>
+            </a:pPr>
+            <a:r>
+              <a:rPr lang="eu-ES" sz="1400" b="1" dirty="0" err="1"/>
+              <a:t>Standard</a:t>
+            </a:r>
+            <a:r>
+              <a:rPr lang="eu-ES" sz="1400" b="1" dirty="0"/>
+              <a:t> </a:t>
+            </a:r>
+            <a:r>
+              <a:rPr lang="eu-ES" sz="1400" b="1" dirty="0" err="1"/>
+              <a:t>Edition</a:t>
+            </a:r>
+            <a:r>
+              <a:rPr lang="eu-ES" sz="1400" b="1" dirty="0"/>
+              <a:t> (</a:t>
+            </a:r>
+            <a:r>
+              <a:rPr lang="eu-ES" sz="1400" b="1" dirty="0" err="1"/>
+              <a:t>Desktop</a:t>
+            </a:r>
+            <a:r>
+              <a:rPr lang="eu-ES" sz="1400" b="1" dirty="0"/>
+              <a:t> </a:t>
+            </a:r>
+            <a:r>
+              <a:rPr lang="eu-ES" sz="1400" b="1" dirty="0" err="1"/>
+              <a:t>Experience</a:t>
+            </a:r>
+            <a:r>
+              <a:rPr lang="eu-ES" sz="1400" b="1" dirty="0"/>
+              <a:t>) / </a:t>
+            </a:r>
+            <a:r>
+              <a:rPr lang="eu-ES" sz="1400" b="1" dirty="0" err="1"/>
+              <a:t>Experiencia</a:t>
+            </a:r>
+            <a:r>
+              <a:rPr lang="eu-ES" sz="1400" b="1" dirty="0"/>
+              <a:t> de </a:t>
+            </a:r>
+            <a:r>
+              <a:rPr lang="eu-ES" sz="1400" b="1" dirty="0" err="1"/>
+              <a:t>escritorio</a:t>
+            </a:r>
+            <a:endParaRPr lang="eu-ES" sz="1400" b="1" dirty="0"/>
+          </a:p>
+          <a:p>
+            <a:pPr>
+              <a:buFontTx/>
+              <a:buChar char="-"/>
+            </a:pPr>
+            <a:endParaRPr lang="eu-ES" sz="1400" b="1" dirty="0"/>
+          </a:p>
+        </p:txBody>
+      </p:sp>
+      <p:sp>
+        <p:nvSpPr>
+          <p:cNvPr id="7" name="Marcador de contenido 2">
+            <a:extLst>
+              <a:ext uri="{FF2B5EF4-FFF2-40B4-BE49-F238E27FC236}">
+                <a16:creationId xmlns:a16="http://schemas.microsoft.com/office/drawing/2014/main" id="{939AC166-7267-0F5B-1984-30F06A759CC0}"/>
+              </a:ext>
+            </a:extLst>
+          </p:cNvPr>
+          <p:cNvSpPr txBox="1">
+            <a:spLocks/>
+          </p:cNvSpPr>
+          <p:nvPr/>
+        </p:nvSpPr>
+        <p:spPr>
+          <a:xfrm>
+            <a:off x="8173703" y="3045376"/>
+            <a:ext cx="3077184" cy="1575786"/>
+          </a:xfrm>
+          <a:prstGeom prst="rect">
+            <a:avLst/>
+          </a:prstGeom>
+        </p:spPr>
+        <p:txBody>
+          <a:bodyPr vert="horz" lIns="91440" tIns="45720" rIns="91440" bIns="45720" rtlCol="0" anchor="ctr">
+            <a:normAutofit/>
+          </a:bodyPr>
+          <a:lstStyle>
+            <a:lvl1pPr marL="342900" indent="-342900" algn="l" defTabSz="457200" rtl="0" eaLnBrk="1" latinLnBrk="0" hangingPunct="1">
+              <a:spcBef>
+                <a:spcPts val="1000"/>
+              </a:spcBef>
+              <a:spcAft>
+                <a:spcPts val="0"/>
+              </a:spcAft>
+              <a:buClr>
+                <a:schemeClr val="bg2">
+                  <a:lumMod val="40000"/>
+                  <a:lumOff val="60000"/>
+                </a:schemeClr>
+              </a:buClr>
+              <a:buSzPct val="80000"/>
+              <a:buFont typeface="Wingdings 3" charset="2"/>
+              <a:buChar char=""/>
+              <a:defRPr sz="2000" b="0" i="0" kern="1200">
+                <a:solidFill>
+                  <a:schemeClr val="tx1"/>
+                </a:solidFill>
+                <a:latin typeface="+mj-lt"/>
+                <a:ea typeface="+mj-ea"/>
+                <a:cs typeface="+mj-cs"/>
+              </a:defRPr>
+            </a:lvl1pPr>
+            <a:lvl2pPr marL="742950" indent="-285750" algn="l" defTabSz="457200" rtl="0" eaLnBrk="1" latinLnBrk="0" hangingPunct="1">
+              <a:spcBef>
+                <a:spcPts val="1000"/>
+              </a:spcBef>
+              <a:spcAft>
+                <a:spcPts val="0"/>
+              </a:spcAft>
+              <a:buClr>
+                <a:schemeClr val="bg2">
+                  <a:lumMod val="40000"/>
+                  <a:lumOff val="60000"/>
+                </a:schemeClr>
+              </a:buClr>
+              <a:buSzPct val="80000"/>
+              <a:buFont typeface="Wingdings 3" charset="2"/>
+              <a:buChar char=""/>
+              <a:defRPr sz="1800" b="0" i="0" kern="1200">
+                <a:solidFill>
+                  <a:schemeClr val="tx1"/>
+                </a:solidFill>
+                <a:latin typeface="+mj-lt"/>
+                <a:ea typeface="+mj-ea"/>
+                <a:cs typeface="+mj-cs"/>
+              </a:defRPr>
+            </a:lvl2pPr>
+            <a:lvl3pPr marL="1143000" indent="-228600" algn="l" defTabSz="457200" rtl="0" eaLnBrk="1" latinLnBrk="0" hangingPunct="1">
+              <a:spcBef>
+                <a:spcPts val="1000"/>
+              </a:spcBef>
+              <a:spcAft>
+                <a:spcPts val="0"/>
+              </a:spcAft>
+              <a:buClr>
+                <a:schemeClr val="bg2">
+                  <a:lumMod val="40000"/>
+                  <a:lumOff val="60000"/>
+                </a:schemeClr>
+              </a:buClr>
+              <a:buSzPct val="80000"/>
+              <a:buFont typeface="Wingdings 3" charset="2"/>
+              <a:buChar char=""/>
+              <a:defRPr sz="1600" b="0" i="0" kern="1200">
+                <a:solidFill>
+                  <a:schemeClr val="tx1"/>
+                </a:solidFill>
+                <a:latin typeface="+mj-lt"/>
+                <a:ea typeface="+mj-ea"/>
+                <a:cs typeface="+mj-cs"/>
+              </a:defRPr>
+            </a:lvl3pPr>
+            <a:lvl4pPr marL="1600200" indent="-228600" algn="l" defTabSz="457200" rtl="0" eaLnBrk="1" latinLnBrk="0" hangingPunct="1">
+              <a:spcBef>
+                <a:spcPts val="1000"/>
+              </a:spcBef>
+              <a:spcAft>
+                <a:spcPts val="0"/>
+              </a:spcAft>
+              <a:buClr>
+                <a:schemeClr val="bg2">
+                  <a:lumMod val="40000"/>
+                  <a:lumOff val="60000"/>
+                </a:schemeClr>
+              </a:buClr>
+              <a:buSzPct val="80000"/>
+              <a:buFont typeface="Wingdings 3" charset="2"/>
+              <a:buChar char=""/>
+              <a:defRPr sz="1400" b="0" i="0" kern="1200">
+                <a:solidFill>
+                  <a:schemeClr val="tx1"/>
+                </a:solidFill>
+                <a:latin typeface="+mj-lt"/>
+                <a:ea typeface="+mj-ea"/>
+                <a:cs typeface="+mj-cs"/>
+              </a:defRPr>
+            </a:lvl4pPr>
+            <a:lvl5pPr marL="2057400" indent="-228600" algn="l" defTabSz="457200" rtl="0" eaLnBrk="1" latinLnBrk="0" hangingPunct="1">
+              <a:spcBef>
+                <a:spcPts val="1000"/>
+              </a:spcBef>
+              <a:spcAft>
+                <a:spcPts val="0"/>
+              </a:spcAft>
+              <a:buClr>
+                <a:schemeClr val="bg2">
+                  <a:lumMod val="40000"/>
+                  <a:lumOff val="60000"/>
+                </a:schemeClr>
+              </a:buClr>
+              <a:buSzPct val="80000"/>
+              <a:buFont typeface="Wingdings 3" charset="2"/>
+              <a:buChar char=""/>
+              <a:defRPr sz="1400" b="0" i="0" kern="1200">
+                <a:solidFill>
+                  <a:schemeClr val="tx1"/>
+                </a:solidFill>
+                <a:latin typeface="+mj-lt"/>
+                <a:ea typeface="+mj-ea"/>
+                <a:cs typeface="+mj-cs"/>
+              </a:defRPr>
+            </a:lvl5pPr>
+            <a:lvl6pPr marL="2506000" indent="-228600" algn="l" defTabSz="457200" rtl="0" eaLnBrk="1" latinLnBrk="0" hangingPunct="1">
+              <a:spcBef>
+                <a:spcPts val="1000"/>
+              </a:spcBef>
+              <a:spcAft>
+                <a:spcPts val="0"/>
+              </a:spcAft>
+              <a:buClr>
+                <a:schemeClr val="bg2">
+                  <a:lumMod val="40000"/>
+                  <a:lumOff val="60000"/>
+                </a:schemeClr>
+              </a:buClr>
+              <a:buSzPct val="80000"/>
+              <a:buFont typeface="Wingdings 3" charset="2"/>
+              <a:buChar char=""/>
+              <a:defRPr sz="1400" b="0" i="0" kern="1200">
+                <a:solidFill>
+                  <a:schemeClr val="tx1"/>
+                </a:solidFill>
+                <a:latin typeface="+mj-lt"/>
+                <a:ea typeface="+mj-ea"/>
+                <a:cs typeface="+mj-cs"/>
+              </a:defRPr>
+            </a:lvl6pPr>
+            <a:lvl7pPr marL="2971800" indent="-228600" algn="l" defTabSz="457200" rtl="0" eaLnBrk="1" latinLnBrk="0" hangingPunct="1">
+              <a:spcBef>
+                <a:spcPts val="1000"/>
+              </a:spcBef>
+              <a:spcAft>
+                <a:spcPts val="0"/>
+              </a:spcAft>
+              <a:buClr>
+                <a:schemeClr val="bg2">
+                  <a:lumMod val="40000"/>
+                  <a:lumOff val="60000"/>
+                </a:schemeClr>
+              </a:buClr>
+              <a:buSzPct val="80000"/>
+              <a:buFont typeface="Wingdings 3" charset="2"/>
+              <a:buChar char=""/>
+              <a:defRPr sz="1400" b="0" i="0" kern="1200">
+                <a:solidFill>
+                  <a:schemeClr val="tx1"/>
+                </a:solidFill>
+                <a:latin typeface="+mj-lt"/>
+                <a:ea typeface="+mj-ea"/>
+                <a:cs typeface="+mj-cs"/>
+              </a:defRPr>
+            </a:lvl7pPr>
+            <a:lvl8pPr marL="3429000" indent="-228600" algn="l" defTabSz="457200" rtl="0" eaLnBrk="1" latinLnBrk="0" hangingPunct="1">
+              <a:spcBef>
+                <a:spcPts val="1000"/>
+              </a:spcBef>
+              <a:spcAft>
+                <a:spcPts val="0"/>
+              </a:spcAft>
+              <a:buClr>
+                <a:schemeClr val="bg2">
+                  <a:lumMod val="40000"/>
+                  <a:lumOff val="60000"/>
+                </a:schemeClr>
+              </a:buClr>
+              <a:buSzPct val="80000"/>
+              <a:buFont typeface="Wingdings 3" charset="2"/>
+              <a:buChar char=""/>
+              <a:defRPr sz="1400" b="0" i="0" kern="1200">
+                <a:solidFill>
+                  <a:schemeClr val="tx1"/>
+                </a:solidFill>
+                <a:latin typeface="+mj-lt"/>
+                <a:ea typeface="+mj-ea"/>
+                <a:cs typeface="+mj-cs"/>
+              </a:defRPr>
+            </a:lvl8pPr>
+            <a:lvl9pPr marL="3886200" indent="-228600" algn="l" defTabSz="457200" rtl="0" eaLnBrk="1" latinLnBrk="0" hangingPunct="1">
+              <a:spcBef>
+                <a:spcPts val="1000"/>
+              </a:spcBef>
+              <a:spcAft>
+                <a:spcPts val="0"/>
+              </a:spcAft>
+              <a:buClr>
+                <a:schemeClr val="bg2">
+                  <a:lumMod val="40000"/>
+                  <a:lumOff val="60000"/>
+                </a:schemeClr>
+              </a:buClr>
+              <a:buSzPct val="80000"/>
+              <a:buFont typeface="Wingdings 3" charset="2"/>
+              <a:buChar char=""/>
+              <a:defRPr sz="1400" b="0" i="0" kern="1200">
+                <a:solidFill>
+                  <a:schemeClr val="tx1"/>
+                </a:solidFill>
+                <a:latin typeface="+mj-lt"/>
+                <a:ea typeface="+mj-ea"/>
+                <a:cs typeface="+mj-cs"/>
+              </a:defRPr>
+            </a:lvl9pPr>
+          </a:lstStyle>
+          <a:p>
+            <a:pPr marL="0" indent="0">
+              <a:buFont typeface="Wingdings 3" charset="2"/>
+              <a:buNone/>
+            </a:pPr>
+            <a:r>
+              <a:rPr lang="eu-ES" sz="1400" b="1" dirty="0"/>
+              <a:t>Hasierako konfigurazioa:</a:t>
+            </a:r>
+          </a:p>
+          <a:p>
+            <a:pPr>
+              <a:buFontTx/>
+              <a:buChar char="-"/>
+            </a:pPr>
+            <a:r>
+              <a:rPr lang="eu-ES" sz="1400" b="1" dirty="0"/>
+              <a:t>Administratzaileari Pasahitza Ezarri</a:t>
+            </a:r>
+          </a:p>
+          <a:p>
+            <a:pPr>
+              <a:buFontTx/>
+              <a:buChar char="-"/>
+            </a:pPr>
+            <a:r>
+              <a:rPr lang="eu-ES" sz="1400" b="1" dirty="0"/>
+              <a:t>Ekipoaren izena aldatu</a:t>
+            </a:r>
+          </a:p>
+          <a:p>
+            <a:pPr>
+              <a:buFontTx/>
+              <a:buChar char="-"/>
+            </a:pPr>
+            <a:r>
+              <a:rPr lang="eu-ES" sz="1400" b="1" dirty="0"/>
+              <a:t>Sistema eguneratu</a:t>
+            </a:r>
+          </a:p>
+        </p:txBody>
+      </p:sp>
+      <p:pic>
+        <p:nvPicPr>
+          <p:cNvPr id="9" name="Imagen 8">
+            <a:extLst>
+              <a:ext uri="{FF2B5EF4-FFF2-40B4-BE49-F238E27FC236}">
+                <a16:creationId xmlns:a16="http://schemas.microsoft.com/office/drawing/2014/main" id="{B57330AB-8B9D-C201-478A-ED5E89E307BF}"/>
+              </a:ext>
+            </a:extLst>
+          </p:cNvPr>
+          <p:cNvPicPr>
+            <a:picLocks noChangeAspect="1"/>
+          </p:cNvPicPr>
+          <p:nvPr/>
+        </p:nvPicPr>
+        <p:blipFill>
+          <a:blip r:embed="rId2">
+            <a:extLst>
+              <a:ext uri="{28A0092B-C50C-407E-A947-70E740481C1C}">
+                <a14:useLocalDpi xmlns:a14="http://schemas.microsoft.com/office/drawing/2010/main" val="0"/>
+              </a:ext>
+            </a:extLst>
+          </a:blip>
+          <a:stretch>
+            <a:fillRect/>
+          </a:stretch>
+        </p:blipFill>
+        <p:spPr>
+          <a:xfrm>
+            <a:off x="3067050" y="5067908"/>
+            <a:ext cx="2035892" cy="1355475"/>
+          </a:xfrm>
+          <a:prstGeom prst="rect">
+            <a:avLst/>
+          </a:prstGeom>
+        </p:spPr>
+      </p:pic>
+      <p:pic>
+        <p:nvPicPr>
+          <p:cNvPr id="11" name="Imagen 10">
+            <a:extLst>
+              <a:ext uri="{FF2B5EF4-FFF2-40B4-BE49-F238E27FC236}">
+                <a16:creationId xmlns:a16="http://schemas.microsoft.com/office/drawing/2014/main" id="{F6DAF512-C1BB-D286-7497-E6007A7D9499}"/>
+              </a:ext>
+            </a:extLst>
+          </p:cNvPr>
+          <p:cNvPicPr>
+            <a:picLocks noChangeAspect="1"/>
+          </p:cNvPicPr>
+          <p:nvPr/>
+        </p:nvPicPr>
+        <p:blipFill>
+          <a:blip r:embed="rId3">
+            <a:extLst>
+              <a:ext uri="{28A0092B-C50C-407E-A947-70E740481C1C}">
+                <a14:useLocalDpi xmlns:a14="http://schemas.microsoft.com/office/drawing/2010/main" val="0"/>
+              </a:ext>
+            </a:extLst>
+          </a:blip>
+          <a:stretch>
+            <a:fillRect/>
+          </a:stretch>
+        </p:blipFill>
+        <p:spPr>
+          <a:xfrm>
+            <a:off x="7089060" y="5067907"/>
+            <a:ext cx="2202424" cy="1355475"/>
+          </a:xfrm>
+          <a:prstGeom prst="rect">
+            <a:avLst/>
+          </a:prstGeom>
+        </p:spPr>
+      </p:pic>
     </p:spTree>
     <p:extLst>
       <p:ext uri="{BB962C8B-B14F-4D97-AF65-F5344CB8AC3E}">
@@ -9015,7 +9791,7 @@
         <p:spPr>
           <a:xfrm>
             <a:off x="1195583" y="3045377"/>
-            <a:ext cx="2314533" cy="2003323"/>
+            <a:ext cx="5854146" cy="2003323"/>
           </a:xfrm>
         </p:spPr>
         <p:txBody>
@@ -9029,42 +9805,16 @@
             </a:pPr>
             <a:r>
               <a:rPr lang="eu-ES" sz="1400" b="1" noProof="0" dirty="0"/>
-              <a:t>Emandako Espezifikazioak:</a:t>
-            </a:r>
-          </a:p>
-          <a:p>
-            <a:pPr>
-              <a:buFontTx/>
-              <a:buChar char="-"/>
+              <a:t>IP FINKOA JARRI DIOGU: 192.168.0.10 (255.255.255.0 Maskara).</a:t>
+            </a:r>
+          </a:p>
+          <a:p>
+            <a:pPr marL="0" indent="0">
+              <a:buNone/>
             </a:pPr>
             <a:r>
               <a:rPr lang="eu-ES" sz="1400" b="1" dirty="0"/>
-              <a:t>4gb</a:t>
-            </a:r>
-          </a:p>
-          <a:p>
-            <a:pPr>
-              <a:buFontTx/>
-              <a:buChar char="-"/>
-            </a:pPr>
-            <a:r>
-              <a:rPr lang="eu-ES" sz="1400" b="1" dirty="0"/>
-              <a:t>2 </a:t>
-            </a:r>
-            <a:r>
-              <a:rPr lang="eu-ES" sz="1400" b="1" dirty="0" err="1"/>
-              <a:t>cpu</a:t>
-            </a:r>
-            <a:endParaRPr lang="eu-ES" sz="1400" b="1" dirty="0"/>
-          </a:p>
-          <a:p>
-            <a:pPr>
-              <a:buFontTx/>
-              <a:buChar char="-"/>
-            </a:pPr>
-            <a:r>
-              <a:rPr lang="eu-ES" sz="1400" b="1" dirty="0"/>
-              <a:t>50gb sistema eragile</a:t>
+              <a:t>ZERTARAKO? Zerbitzariak sarera konektatu bakoitzean IP ezberdina izan ez dezan.</a:t>
             </a:r>
           </a:p>
           <a:p>
@@ -9119,6 +9869,42 @@
           </a:p>
         </p:txBody>
       </p:sp>
+      <p:pic>
+        <p:nvPicPr>
+          <p:cNvPr id="6" name="Imagen 5">
+            <a:extLst>
+              <a:ext uri="{FF2B5EF4-FFF2-40B4-BE49-F238E27FC236}">
+                <a16:creationId xmlns:a16="http://schemas.microsoft.com/office/drawing/2014/main" id="{094EB918-8F44-4A3D-5589-4E385A310C97}"/>
+              </a:ext>
+            </a:extLst>
+          </p:cNvPr>
+          <p:cNvPicPr>
+            <a:picLocks noChangeAspect="1"/>
+          </p:cNvPicPr>
+          <p:nvPr/>
+        </p:nvPicPr>
+        <p:blipFill>
+          <a:blip r:embed="rId2">
+            <a:extLst>
+              <a:ext uri="{28A0092B-C50C-407E-A947-70E740481C1C}">
+                <a14:useLocalDpi xmlns:a14="http://schemas.microsoft.com/office/drawing/2010/main" val="0"/>
+              </a:ext>
+            </a:extLst>
+          </a:blip>
+          <a:stretch>
+            <a:fillRect/>
+          </a:stretch>
+        </p:blipFill>
+        <p:spPr>
+          <a:xfrm>
+            <a:off x="7049729" y="2260111"/>
+            <a:ext cx="4228296" cy="3880133"/>
+          </a:xfrm>
+          <a:prstGeom prst="rect">
+            <a:avLst/>
+          </a:prstGeom>
+        </p:spPr>
+      </p:pic>
     </p:spTree>
     <p:extLst>
       <p:ext uri="{BB962C8B-B14F-4D97-AF65-F5344CB8AC3E}">

</xml_diff>